<commit_message>
Fix presentation text: ASCII-safe glyphs and full-width bullet boxes
Two rendering defects in the decks:
- Math/exotic Unicode (subscripts/superscripts, ceiling brackets, double-struck Z,
  arrows, chi/Delta, etc.) showed as missing-glyph boxes in PowerPoint. Added an
  ascii_safe() normalizer: e.g. Z_256, ceil(log_256 n), K[s(j)]^-1, chi^2, 100/MN,
  "->", "~"; kept safe typography (dashes, curly quotes, middle dot, x).
- Bullet slides set only top/height on the content placeholder, which defaulted its
  left/width to 0 -> a zero-width text box. Now all four position attributes are set
  explicitly (full-width bullets).

Regenerated both decks; verified no risky glyphs and no zero-width placeholders remain,
content still clears the footer banner.

Co-Authored-By: Claude Opus 4.8 <noreply@anthropic.com>
Claude-Session: https://claude.ai/code/session_012hkrNLaTdTLUrTK6mv5mcS
</commit_message>
<xml_diff>
--- a/papers/paper1-chaos-cpa/presentation.pptx
+++ b/papers/paper1-chaos-cpa/presentation.pptx
@@ -2992,7 +2992,7 @@
                   <a:srgbClr val="1F3355"/>
                 </a:solidFill>
               </a:rPr>
-              <a:t>A chi-square test rejects uniformity for the logistic (χ² ≈ 5.3×10⁵) and Lorenz keystreams.</a:t>
+              <a:t>A chi-square test rejects uniformity for the logistic (chi^2 ~ 5.3×10^5) and Lorenz keystreams.</a:t>
             </a:r>
           </a:p>
           <a:p>
@@ -3102,8 +3102,8 @@
         </p:nvSpPr>
         <p:spPr>
           <a:xfrm>
-            <a:off x="0" y="1783080"/>
-            <a:ext cx="0" cy="4114800"/>
+            <a:off x="640080" y="1783080"/>
+            <a:ext cx="10927080" cy="4114800"/>
           </a:xfrm>
         </p:spPr>
         <p:txBody>
@@ -3212,8 +3212,8 @@
         </p:nvSpPr>
         <p:spPr>
           <a:xfrm>
-            <a:off x="0" y="1783080"/>
-            <a:ext cx="0" cy="4114800"/>
+            <a:off x="640080" y="1783080"/>
+            <a:ext cx="10927080" cy="4114800"/>
           </a:xfrm>
         </p:spPr>
         <p:txBody>
@@ -3337,8 +3337,8 @@
         </p:nvSpPr>
         <p:spPr>
           <a:xfrm>
-            <a:off x="0" y="1783080"/>
-            <a:ext cx="0" cy="4114800"/>
+            <a:off x="640080" y="1783080"/>
+            <a:ext cx="10927080" cy="4114800"/>
           </a:xfrm>
         </p:spPr>
         <p:txBody>
@@ -3371,7 +3371,7 @@
                   <a:srgbClr val="1F3355"/>
                 </a:solidFill>
               </a:rPr>
-              <a:t>Cost scales logarithmically: 3 chosen plaintexts at 128²/256², 4 at 512²/1024², each under 0.3 s.</a:t>
+              <a:t>Cost scales logarithmically: 3 chosen plaintexts at 128^2/256^2, 4 at 512^2/1024^2, each under 0.3 s.</a:t>
             </a:r>
           </a:p>
           <a:p>
@@ -3447,8 +3447,8 @@
         </p:nvSpPr>
         <p:spPr>
           <a:xfrm>
-            <a:off x="0" y="1783080"/>
-            <a:ext cx="0" cy="4114800"/>
+            <a:off x="640080" y="1783080"/>
+            <a:ext cx="10927080" cy="4114800"/>
           </a:xfrm>
         </p:spPr>
         <p:txBody>
@@ -3674,8 +3674,8 @@
         </p:nvSpPr>
         <p:spPr>
           <a:xfrm>
-            <a:off x="0" y="1783080"/>
-            <a:ext cx="0" cy="4114800"/>
+            <a:off x="640080" y="1783080"/>
+            <a:ext cx="10927080" cy="4114800"/>
           </a:xfrm>
         </p:spPr>
         <p:txBody>
@@ -3999,8 +3999,8 @@
         </p:nvSpPr>
         <p:spPr>
           <a:xfrm>
-            <a:off x="0" y="1783080"/>
-            <a:ext cx="0" cy="4114800"/>
+            <a:off x="640080" y="1783080"/>
+            <a:ext cx="10927080" cy="4114800"/>
           </a:xfrm>
         </p:spPr>
         <p:txBody>
@@ -4018,7 +4018,7 @@
                   <a:srgbClr val="1F3355"/>
                 </a:solidFill>
               </a:rPr>
-              <a:t>Index the image as a length-n vector, n = M·N. Each step is linear over ℤ₂₅₆ and fixed by the key.</a:t>
+              <a:t>Index the image as a length-n vector, n = M·N. Each step is linear over Z_256 and fixed by the key.</a:t>
             </a:r>
           </a:p>
           <a:p>
@@ -4048,7 +4048,7 @@
                   <a:srgbClr val="1F3355"/>
                 </a:solidFill>
               </a:rPr>
-              <a:t>Therefore  C[j] = K[s(j)] · X[s(j)]  (mod 256),  with s = P⁻¹ — a fixed monomial map.</a:t>
+              <a:t>Therefore  C[j] = K[s(j)] · X[s(j)]  (mod 256),  with s = P^-1 — a fixed monomial map.</a:t>
             </a:r>
           </a:p>
           <a:p>
@@ -4124,8 +4124,8 @@
         </p:nvSpPr>
         <p:spPr>
           <a:xfrm>
-            <a:off x="0" y="1783080"/>
-            <a:ext cx="0" cy="4114800"/>
+            <a:off x="640080" y="1783080"/>
+            <a:ext cx="10927080" cy="4114800"/>
           </a:xfrm>
         </p:spPr>
         <p:txBody>
@@ -4143,7 +4143,7 @@
                   <a:srgbClr val="1F3355"/>
                 </a:solidFill>
               </a:rPr>
-              <a:t>(a) Multiplier — one query: encrypt the all-ones image → C[j] = K[s(j)] (the multiplier at every output position).</a:t>
+              <a:t>(a) Multiplier — one query: encrypt the all-ones image -&gt; C[j] = K[s(j)] (the multiplier at every output position).</a:t>
             </a:r>
           </a:p>
           <a:p>
@@ -4158,7 +4158,7 @@
                   <a:srgbClr val="1F3355"/>
                 </a:solidFill>
               </a:rPr>
-              <a:t>(b) Permutation — ⌈log₂₅₆ n⌉ queries: index-digit images; divide by the known K → recover the source map s.</a:t>
+              <a:t>(b) Permutation — ceil(log_256 n) queries: index-digit images; divide by the known K -&gt; recover the source map s.</a:t>
             </a:r>
           </a:p>
           <a:p>
@@ -4173,7 +4173,7 @@
                   <a:srgbClr val="1F3355"/>
                 </a:solidFill>
               </a:rPr>
-              <a:t>Equivalent key (s, K) inverts any ciphertext:  X[s(j)] = K[s(j)]⁻¹ · C[j].</a:t>
+              <a:t>Equivalent key (s, K) inverts any ciphertext:  X[s(j)] = K[s(j)]^-1 · C[j].</a:t>
             </a:r>
           </a:p>
           <a:p>
@@ -4188,7 +4188,7 @@
                   <a:srgbClr val="1F3355"/>
                 </a:solidFill>
               </a:rPr>
-              <a:t>Cost: 1 + ⌈log₂₅₆ MN⌉ chosen plaintexts = 4 for a 512×512 image — independent of the advertised key length.</a:t>
+              <a:t>Cost: 1 + ceil(log_256 MN) chosen plaintexts = 4 for a 512×512 image — independent of the advertised key length.</a:t>
             </a:r>
           </a:p>
           <a:p>
@@ -4264,8 +4264,8 @@
         </p:nvSpPr>
         <p:spPr>
           <a:xfrm>
-            <a:off x="0" y="1783080"/>
-            <a:ext cx="0" cy="4114800"/>
+            <a:off x="640080" y="1783080"/>
+            <a:ext cx="10927080" cy="4114800"/>
           </a:xfrm>
         </p:spPr>
         <p:txBody>
@@ -4498,7 +4498,7 @@
                   <a:srgbClr val="555555"/>
                 </a:solidFill>
               </a:rPr>
-              <a:t>Original → LLEO ciphertext → key-free recovery (bit-identical), four images.</a:t>
+              <a:t>Original -&gt; LLEO ciphertext -&gt; key-free recovery (bit-identical), four images.</a:t>
             </a:r>
           </a:p>
         </p:txBody>
@@ -4542,7 +4542,7 @@
                   <a:srgbClr val="1F3355"/>
                 </a:solidFill>
               </a:rPr>
-              <a:t>Good statistics ≠ security</a:t>
+              <a:t>Good statistics are not security</a:t>
             </a:r>
           </a:p>
         </p:txBody>
@@ -4658,7 +4658,7 @@
                   <a:srgbClr val="555555"/>
                 </a:solidFill>
               </a:rPr>
-              <a:t>Adjacent-pixel density: structure → uniform</a:t>
+              <a:t>Adjacent-pixel density: structure -&gt; uniform</a:t>
             </a:r>
           </a:p>
         </p:txBody>
@@ -4696,7 +4696,7 @@
                   <a:srgbClr val="1F3355"/>
                 </a:solidFill>
               </a:rPr>
-              <a:t>Cipher entropy 7.23 → 7.99 (near-ideal 8); adjacent-pixel correlation ≈ −0.007 (near zero); flat histogram.</a:t>
+              <a:t>Cipher entropy 7.23 -&gt; 7.99 (near-ideal 8); adjacent-pixel correlation ~ -0.007 (near zero); flat histogram.</a:t>
             </a:r>
           </a:p>
           <a:p>
@@ -4817,7 +4817,7 @@
                   <a:srgbClr val="1F3355"/>
                 </a:solidFill>
               </a:rPr>
-              <a:t>LLEO reports NPCR ≈ 99.6% as differential-attack resistance.</a:t>
+              <a:t>LLEO reports NPCR ~ 99.6% as differential-attack resistance.</a:t>
             </a:r>
           </a:p>
           <a:p>
@@ -4832,7 +4832,7 @@
                   <a:srgbClr val="1F3355"/>
                 </a:solidFill>
               </a:rPr>
-              <a:t>No diffusion → a one-pixel change alters exactly one ciphertext pixel: true NPCR = 100/MN ≈ 0.0004%.</a:t>
+              <a:t>No diffusion -&gt; a one-pixel change alters exactly one ciphertext pixel: true NPCR = 100/MN ~ 0.0004%.</a:t>
             </a:r>
           </a:p>
           <a:p>
@@ -4881,7 +4881,7 @@
                   <a:srgbClr val="555555"/>
                 </a:solidFill>
               </a:rPr>
-              <a:t>|C₀−C₁|: dark = unchanged, bright = changed (one fixed key).</a:t>
+              <a:t>|C_0-C_1|: dark = unchanged, bright = changed (one fixed key).</a:t>
             </a:r>
           </a:p>
         </p:txBody>

</xml_diff>

<commit_message>
Decks: apply the readability lenses (tagline-led titles, assertive header, hero figures)
- Both title slides now front-load the thesis (lens 5): cipher "Good statistics are
  not security: a 2025 cipher broken in 4 chosen plaintexts"; IDS "The much-cited
  'detection collapse' on unknown attacks is mostly a thresholding artifact".
- Cipher attack slide retitled "Four images recover the full map" to match the
  paper's assertive section header (lens 4).
- The two hero-figure images (break_grid banner, combined_pipeline punchline title)
  were already regenerated and remain embedded (lens 6).

Co-Authored-By: Claude Opus 4.8 <noreply@anthropic.com>
Claude-Session: https://claude.ai/code/session_012hkrNLaTdTLUrTK6mv5mcS
</commit_message>
<xml_diff>
--- a/papers/paper1-chaos-cpa/presentation.pptx
+++ b/papers/paper1-chaos-cpa/presentation.pptx
@@ -2858,6 +2858,21 @@
                   <a:srgbClr val="1F3355"/>
                 </a:solidFill>
               </a:rPr>
+              <a:t>Good statistics are not security: a 2025 cipher broken in 4 chosen plaintexts</a:t>
+            </a:r>
+          </a:p>
+          <a:p>
+            <a:pPr algn="ctr">
+              <a:spcAft>
+                <a:spcPts val="400"/>
+              </a:spcAft>
+            </a:pPr>
+            <a:r>
+              <a:rPr sz="1800">
+                <a:solidFill>
+                  <a:srgbClr val="1F3355"/>
+                </a:solidFill>
+              </a:rPr>
               <a:t>UBMK’25 · International Conference on Computer Science and Engineering</a:t>
             </a:r>
           </a:p>
@@ -4476,7 +4491,7 @@
                   <a:srgbClr val="1F3355"/>
                 </a:solidFill>
               </a:rPr>
-              <a:t>Equivalent-key chosen-plaintext attack</a:t>
+              <a:t>Four images recover the full map</a:t>
             </a:r>
           </a:p>
         </p:txBody>

</xml_diff>

<commit_message>
Presentations: mirror the restyle's operational-stakes beat
Add the "Why this matters operationally" beat to each deck's intro slide,
matching the house-style framing now in the papers: cipher deck gains the
upstream-decisions/standing-decrypt-capability/attack-model-not-statistics
framing; IDS deck gains the "a missed novel attack reaches production
before any analyst reviews it" stakes. Content-only edits (slide counts
unchanged at 17/20); all numbers already matched the papers. Both intro
text boxes remain in-bounds with auto-fit, so no overflow.

Co-Authored-By: Claude Opus 4.8 <noreply@anthropic.com>
Claude-Session: https://claude.ai/code/session_012hkrNLaTdTLUrTK6mv5mcS
</commit_message>
<xml_diff>
--- a/papers/paper1-chaos-cpa/presentation.pptx
+++ b/papers/paper1-chaos-cpa/presentation.pptx
@@ -4121,6 +4121,21 @@
                 </a:solidFill>
               </a:rPr>
               <a:t>But none of those scores tests resistance to a chosen-plaintext attack.</a:t>
+            </a:r>
+          </a:p>
+          <a:p>
+            <a:pPr>
+              <a:spcAft>
+                <a:spcPts val="400"/>
+              </a:spcAft>
+            </a:pPr>
+            <a:r>
+              <a:rPr sz="1800">
+                <a:solidFill>
+                  <a:srgbClr val="1F3355"/>
+                </a:solidFill>
+              </a:rPr>
+              <a:t>Why this matters operationally: image ciphers protect real data — medical scans, sealed evidence, access-controlled documents. A break is not a per-image slip but a standing ability to decrypt every future ciphertext of that size, so security must rest on an attack model, not a statistics table.</a:t>
             </a:r>
           </a:p>
           <a:p>

</xml_diff>

<commit_message>
Decks: adopt the cohesive deep-blue/gold palette from the redesign assets
Apply the uploaded redesign's professional palette to the deck generator
(titles + lead bullets deep blue #1F4E6B, accent gold #B08A3E, sub-text
slate #6B7079), replacing the prior navy/vermillion. Colors only; slide
structure, text, figures, and counts (18 / 20) are unchanged.

Deliberately NOT imported from the asset pack: the restyled figure PNGs
(mixed fidelity -- oracle_corpus is faithful but beta_before_after is a
data-stripped schematic; raster vs. our vector PDFs; would desync from the
figure scripts; red=broken/green=resists regresses our colorblind-safe
marker-shape system) and the branding strips (the official UBMK template
already supplies the banner/logos).

Co-Authored-By: Claude Opus 4.8 <noreply@anthropic.com>
Claude-Session: https://claude.ai/code/session_012hkrNLaTdTLUrTK6mv5mcS
</commit_message>
<xml_diff>
--- a/papers/paper1-chaos-cpa/presentation.pptx
+++ b/papers/paper1-chaos-cpa/presentation.pptx
@@ -2818,7 +2818,7 @@
             <a:r>
               <a:rPr sz="3000" b="1">
                 <a:solidFill>
-                  <a:srgbClr val="1F3355"/>
+                  <a:srgbClr val="1F4E6B"/>
                 </a:solidFill>
               </a:rPr>
               <a:t>An Equivalent-Key Chosen-Plaintext Break of a 2025 Chaos-Based Image Cipher</a:t>
@@ -2856,7 +2856,7 @@
             <a:r>
               <a:rPr sz="1800">
                 <a:solidFill>
-                  <a:srgbClr val="1F3355"/>
+                  <a:srgbClr val="1F4E6B"/>
                 </a:solidFill>
               </a:rPr>
               <a:t>Good statistics are not security: a 2025 cipher broken in 4 chosen plaintexts</a:t>
@@ -2871,7 +2871,7 @@
             <a:r>
               <a:rPr sz="1800">
                 <a:solidFill>
-                  <a:srgbClr val="1F3355"/>
+                  <a:srgbClr val="1F4E6B"/>
                 </a:solidFill>
               </a:rPr>
               <a:t>UBMK’25 · International Conference on Computer Science and Engineering</a:t>
@@ -2886,7 +2886,7 @@
             <a:r>
               <a:rPr sz="1800">
                 <a:solidFill>
-                  <a:srgbClr val="1F3355"/>
+                  <a:srgbClr val="1F4E6B"/>
                 </a:solidFill>
               </a:rPr>
               <a:t>Track: Computer and Data Security</a:t>
@@ -2901,7 +2901,7 @@
             <a:r>
               <a:rPr sz="1800">
                 <a:solidFill>
-                  <a:srgbClr val="1F3355"/>
+                  <a:srgbClr val="1F4E6B"/>
                 </a:solidFill>
               </a:rPr>
               <a:t>Author(s) and affiliation withheld for review</a:t>
@@ -2945,7 +2945,7 @@
             <a:r>
               <a:rPr sz="3000" b="1">
                 <a:solidFill>
-                  <a:srgbClr val="1F3355"/>
+                  <a:srgbClr val="1F4E6B"/>
                 </a:solidFill>
               </a:rPr>
               <a:t>Even the chaotic keystreams are not evenly random</a:t>
@@ -3007,7 +3007,7 @@
             <a:r>
               <a:rPr sz="1600">
                 <a:solidFill>
-                  <a:srgbClr val="1F3355"/>
+                  <a:srgbClr val="1F4E6B"/>
                 </a:solidFill>
               </a:rPr>
               <a:t>A chi-square test (a standard check for whether values are evenly spread) strongly rejects “evenly random” for both chaotic streams (logistic chi^2 ~ 5.3×10^5).</a:t>
@@ -3022,7 +3022,7 @@
             <a:r>
               <a:rPr sz="1600">
                 <a:solidFill>
-                  <a:srgbClr val="1F3355"/>
+                  <a:srgbClr val="1F4E6B"/>
                 </a:solidFill>
               </a:rPr>
               <a:t>A secure keystream would be flat, like the uniform reference row at the bottom.</a:t>
@@ -3056,7 +3056,7 @@
             <a:r>
               <a:rPr sz="1200" i="1">
                 <a:solidFill>
-                  <a:srgbClr val="555555"/>
+                  <a:srgbClr val="6B7079"/>
                 </a:solidFill>
               </a:rPr>
               <a:t>How often each byte value appears: logistic and Lorenz vs. a truly uniform source.</a:t>
@@ -3100,7 +3100,7 @@
             <a:r>
               <a:rPr sz="3000" b="1">
                 <a:solidFill>
-                  <a:srgbClr val="1F3355"/>
+                  <a:srgbClr val="1F4E6B"/>
                 </a:solidFill>
               </a:rPr>
               <a:t>The contribution: a reusable structural audit</a:t>
@@ -3162,7 +3162,7 @@
             <a:r>
               <a:rPr sz="1600">
                 <a:solidFill>
-                  <a:srgbClr val="1F3355"/>
+                  <a:srgbClr val="1F4E6B"/>
                 </a:solidFill>
               </a:rPr>
               <a:t>We package the attack as a black-box test: given only the ability to encrypt chosen images, it decides whether a cipher is one fixed plaintext-independent map and, if so, recovers an equivalent key, knowing nothing about the scheme inside, and CERTIFYING each verdict by predicting fresh ciphertext exactly (a check we prove sound).</a:t>
@@ -3177,7 +3177,7 @@
             <a:r>
               <a:rPr sz="1600">
                 <a:solidFill>
-                  <a:srgbClr val="1F3355"/>
+                  <a:srgbClr val="1F4E6B"/>
                 </a:solidFill>
               </a:rPr>
               <a:t>On 8 structural archetypes it breaks all 5 fully key-only ones at R = 1 in &lt;= 5 chosen plaintexts (chaos, permutation, additive, affine, even a modern AES-CTR key stream); 2 image-/nonce-bound schemes correctly resist; a 6th, with non-invertible multipliers, degrades GRACEFULLY (R = 0.52, PARTIAL), the deliberate boundary.</a:t>
@@ -3192,7 +3192,7 @@
             <a:r>
               <a:rPr sz="1600">
                 <a:solidFill>
-                  <a:srgbClr val="1F3355"/>
+                  <a:srgbClr val="1F4E6B"/>
                 </a:solidFill>
               </a:rPr>
               <a:t>The chaos was never the point: a reused, image-independent keystream is. This is a reusable audit, not a one-paper break.</a:t>
@@ -3226,7 +3226,7 @@
             <a:r>
               <a:rPr sz="1200" i="1">
                 <a:solidFill>
-                  <a:srgbClr val="555555"/>
+                  <a:srgbClr val="6B7079"/>
                 </a:solidFill>
               </a:rPr>
               <a:t>Recoverability R per scheme on an archetype corpus (red = broken, green = resists); chosen plaintexts at 512x512.</a:t>
@@ -3270,7 +3270,7 @@
             <a:r>
               <a:rPr sz="3000" b="1">
                 <a:solidFill>
-                  <a:srgbClr val="1F3355"/>
+                  <a:srgbClr val="1F4E6B"/>
                 </a:solidFill>
               </a:rPr>
               <a:t>Run on four real published 2023–2025 ciphers</a:t>
@@ -3332,7 +3332,7 @@
             <a:r>
               <a:rPr sz="1600">
                 <a:solidFill>
-                  <a:srgbClr val="1F3355"/>
+                  <a:srgbClr val="1F4E6B"/>
                 </a:solidFill>
               </a:rPr>
               <a:t>We reconstructed four real, open-access chaos image ciphers from their equations and ran the audit. Each reproduces the originals' near-ideal entropy (~7.99) and inter-image NPCR (~99.6%), so the rebuilds behave like the published ciphers where it counts.</a:t>
@@ -3347,7 +3347,7 @@
             <a:r>
               <a:rPr sz="1600">
                 <a:solidFill>
-                  <a:srgbClr val="1F3355"/>
+                  <a:srgbClr val="1F4E6B"/>
                 </a:solidFill>
               </a:rPr>
               <a:t>Seeding decides the verdict. LSCM-CA (Sun et al. 2025) is key-only -&gt; BROKEN (R = 1.0, 12 chosen plaintexts), but only after a GF(2)-affine 'bitlinear' extension to peel its per-pixel cellular-automata layer, which the plain affine/XOR model misses. The other three bind the keystream to the plaintext (SHA-256 / block sum) -&gt; correctly RESIST.</a:t>
@@ -3362,7 +3362,7 @@
             <a:r>
               <a:rPr sz="1600">
                 <a:solidFill>
-                  <a:srgbClr val="1F3355"/>
+                  <a:srgbClr val="1F4E6B"/>
                 </a:solidFill>
               </a:rPr>
               <a:t>Honest limits: two 'resists' are thin (one injects only a 256-way scalar; one collapses if a 64-pixel seed block is fixed), and the two cheap signals cannot tell genuine binding from a near-miss. We mark this, not hide it. Reconstructions are paper-only; LLEO is the one fully-validated break.</a:t>
@@ -3396,7 +3396,7 @@
             <a:r>
               <a:rPr sz="1200" i="1">
                 <a:solidFill>
-                  <a:srgbClr val="555555"/>
+                  <a:srgbClr val="6B7079"/>
                 </a:solidFill>
               </a:rPr>
               <a:t>The audit in its two signals (avalanche vs. recoverability) on real schemes rebuilt from their papers.</a:t>
@@ -3440,7 +3440,7 @@
             <a:r>
               <a:rPr sz="3000" b="1">
                 <a:solidFill>
-                  <a:srgbClr val="1F3355"/>
+                  <a:srgbClr val="1F4E6B"/>
                 </a:solidFill>
               </a:rPr>
               <a:t>The graded fix: plaintext-keying capacity beta</a:t>
@@ -3502,7 +3502,7 @@
             <a:r>
               <a:rPr sz="1600">
                 <a:solidFill>
-                  <a:srgbClr val="1F3355"/>
+                  <a:srgbClr val="1F4E6B"/>
                 </a:solidFill>
               </a:rPr>
               <a:t>The avalanche and recoverability signals cannot tell a fragile near-miss from genuine binding: the two schemes overlap (left). So we add a graded capacity beta: how many genuinely different ciphers the plaintext can switch the cipher's map between.</a:t>
@@ -3517,7 +3517,7 @@
             <a:r>
               <a:rPr sz="1600">
                 <a:solidFill>
-                  <a:srgbClr val="1F3355"/>
+                  <a:srgbClr val="1F4E6B"/>
                 </a:solidFill>
               </a:rPr>
               <a:t>beta = 0 means one fixed map (key-only, BROKEN); a large beta means every image gets its own unrelated map (RESISTS). It is estimated black-box from chosen plaintexts as a collision rate.</a:t>
@@ -3532,7 +3532,7 @@
             <a:r>
               <a:rPr sz="1600">
                 <a:solidFill>
-                  <a:srgbClr val="1F3355"/>
+                  <a:srgbClr val="1F4E6B"/>
                 </a:solidFill>
               </a:rPr>
               <a:t>So beta separates the schemes the two signals could not: a fragile 256-way scalar (beta = 8) from genuine SHA-256 binding (beta &gt;= 32), turning the one-bit verdict into a measured, falsifiable gap.</a:t>
@@ -3566,7 +3566,7 @@
             <a:r>
               <a:rPr sz="1200" i="1">
                 <a:solidFill>
-                  <a:srgbClr val="555555"/>
+                  <a:srgbClr val="6B7079"/>
                 </a:solidFill>
               </a:rPr>
               <a:t>Left: the two cheap signals overlap. Right: the beta axis separates fragile from genuine.</a:t>
@@ -3610,7 +3610,7 @@
             <a:r>
               <a:rPr sz="3000" b="1">
                 <a:solidFill>
-                  <a:srgbClr val="1F3355"/>
+                  <a:srgbClr val="1F4E6B"/>
                 </a:solidFill>
               </a:rPr>
               <a:t>Discussion: good statistics are not security</a:t>
@@ -3648,7 +3648,7 @@
             <a:r>
               <a:rPr sz="1800">
                 <a:solidFill>
-                  <a:srgbClr val="1F3355"/>
+                  <a:srgbClr val="1F4E6B"/>
                 </a:solidFill>
               </a:rPr>
               <a:t>A flat histogram, ideal entropy, near-zero correlation, and a large inter-image NPCR all hold for our fixed, key-only map, yet it is broken in 4 queries.</a:t>
@@ -3663,7 +3663,7 @@
             <a:r>
               <a:rPr sz="1800">
                 <a:solidFill>
-                  <a:srgbClr val="1F3355"/>
+                  <a:srgbClr val="1F4E6B"/>
                 </a:solidFill>
               </a:rPr>
               <a:t>The single deciding question is binary: does any key material depend on the image? The oracle answers it automatically for any scheme.</a:t>
@@ -3678,7 +3678,7 @@
             <a:r>
               <a:rPr sz="1800">
                 <a:solidFill>
-                  <a:srgbClr val="1F3355"/>
+                  <a:srgbClr val="1F4E6B"/>
                 </a:solidFill>
               </a:rPr>
               <a:t>The break is sound by construction: LLEO forces its multipliers odd (always invertible), and the equivalent key predicts fresh ciphertexts exactly, the falsifiable check that the cipher truly ignores the image.</a:t>
@@ -3693,7 +3693,7 @@
             <a:r>
               <a:rPr sz="1800">
                 <a:solidFill>
-                  <a:srgbClr val="1F3355"/>
+                  <a:srgbClr val="1F4E6B"/>
                 </a:solidFill>
               </a:rPr>
               <a:t>(The scheme's 'asymmetric' label is also a misnomer, same keys encrypt and decrypt, but that is cosmetic.)</a:t>
@@ -3737,7 +3737,7 @@
             <a:r>
               <a:rPr sz="3000" b="1">
                 <a:solidFill>
-                  <a:srgbClr val="1F3355"/>
+                  <a:srgbClr val="1F4E6B"/>
                 </a:solidFill>
               </a:rPr>
               <a:t>Conclusions, remedies, and disclosure</a:t>
@@ -3775,7 +3775,7 @@
             <a:r>
               <a:rPr sz="1800">
                 <a:solidFill>
-                  <a:srgbClr val="1F3355"/>
+                  <a:srgbClr val="1F4E6B"/>
                 </a:solidFill>
               </a:rPr>
               <a:t>LLEO is completely broken by an equivalent-key chosen-plaintext attack in 4 queries and a fraction of a second, despite near-ideal statistics.</a:t>
@@ -3790,7 +3790,7 @@
             <a:r>
               <a:rPr sz="1800">
                 <a:solidFill>
-                  <a:srgbClr val="1F3355"/>
+                  <a:srgbClr val="1F4E6B"/>
                 </a:solidFill>
               </a:rPr>
               <a:t>More than one break: the audit flags every fully key-only scheme in an 8-archetype corpus and, on four real published 2023-2025 ciphers, breaks the one key-only design (LSCM-CA) and clears three plaintext-bound ones, one break needing a GF(2)-affine extension.</a:t>
@@ -3805,7 +3805,7 @@
             <a:r>
               <a:rPr sz="1800">
                 <a:solidFill>
-                  <a:srgbClr val="1F3355"/>
+                  <a:srgbClr val="1F4E6B"/>
                 </a:solidFill>
               </a:rPr>
               <a:t>Remedies (standard): (i) tie the keystream to the image (seed the chaos from a SHA-256 hash of the image); (ii) add real diffusion (a chaining rule). The identical attack then recovers 100% of pixels against the key-only cipher but only 0.25% (chance) once the keystream is image-seeded.</a:t>
@@ -3820,7 +3820,7 @@
             <a:r>
               <a:rPr sz="1800">
                 <a:solidFill>
-                  <a:srgbClr val="1F3355"/>
+                  <a:srgbClr val="1F4E6B"/>
                 </a:solidFill>
               </a:rPr>
               <a:t>Statistical scores should support, not replace, an explicit chosen-plaintext argument. Authors of both broken schemes (LLEO and LSCM-CA) emailed at submission; no response yet (responsible disclosure).</a:t>
@@ -3864,7 +3864,7 @@
             <a:r>
               <a:rPr sz="3000" b="1">
                 <a:solidFill>
-                  <a:srgbClr val="1F3355"/>
+                  <a:srgbClr val="1F4E6B"/>
                 </a:solidFill>
               </a:rPr>
               <a:t>Appendix: why the break is sound (invertibility &amp; fidelity)</a:t>
@@ -3902,7 +3902,7 @@
             <a:r>
               <a:rPr sz="1800">
                 <a:solidFill>
-                  <a:srgbClr val="1F3355"/>
+                  <a:srgbClr val="1F4E6B"/>
                 </a:solidFill>
               </a:rPr>
               <a:t>Odd multipliers: LLEO inverts its substitution by a modular conjugate, which forces every multiplier odd (always invertible mod 256). On the reconstruction all are odd and E(0)=0 holds exactly; if even multipliers were allowed the oracle degrades gracefully (about half the positions recovered) rather than returning a wrong inverse.</a:t>
@@ -3917,7 +3917,7 @@
             <a:r>
               <a:rPr sz="1800">
                 <a:solidFill>
-                  <a:srgbClr val="1F3355"/>
+                  <a:srgbClr val="1F4E6B"/>
                 </a:solidFill>
               </a:rPr>
               <a:t>Fidelity: matching entropy/correlation proves nothing. The load-bearing check is that the recovered key predicts fresh ciphertexts exactly, which only a plaintext-independent cipher can.</a:t>
@@ -3932,7 +3932,7 @@
             <a:r>
               <a:rPr sz="1800">
                 <a:solidFill>
-                  <a:srgbClr val="1F3355"/>
+                  <a:srgbClr val="1F4E6B"/>
                 </a:solidFill>
               </a:rPr>
               <a:t>Generality &amp; scale: a very different XOR-and-chain (CBC-like) cipher also falls in 3-4 chosen plaintexts; cost grows only logarithmically with image size (3-4 plaintexts up to 1024x1024).</a:t>
@@ -3976,7 +3976,7 @@
             <a:r>
               <a:rPr sz="3000" b="1">
                 <a:solidFill>
-                  <a:srgbClr val="1F3355"/>
+                  <a:srgbClr val="1F4E6B"/>
                 </a:solidFill>
               </a:rPr>
               <a:t>Selected references</a:t>
@@ -4014,7 +4014,7 @@
             <a:r>
               <a:rPr sz="1800">
                 <a:solidFill>
-                  <a:srgbClr val="1F3355"/>
+                  <a:srgbClr val="1F4E6B"/>
                 </a:solidFill>
               </a:rPr>
               <a:t>J. Jain et al., LLEO chaos-based image-encryption scheme, Optik 327:172304, 2025  (target scheme).</a:t>
@@ -4029,7 +4029,7 @@
             <a:r>
               <a:rPr sz="1800">
                 <a:solidFill>
-                  <a:srgbClr val="1F3355"/>
+                  <a:srgbClr val="1F4E6B"/>
                 </a:solidFill>
               </a:rPr>
               <a:t>C. Li et al., “When an attacker meets a cipher-image,” survey of chaos-cipher breaks, 2019.</a:t>
@@ -4044,7 +4044,7 @@
             <a:r>
               <a:rPr sz="1800">
                 <a:solidFill>
-                  <a:srgbClr val="1F3355"/>
+                  <a:srgbClr val="1F4E6B"/>
                 </a:solidFill>
               </a:rPr>
               <a:t>G. Alvarez and S. Li, “Some basic cryptographic requirements for chaos-based cryptosystems,” 2006.</a:t>
@@ -4059,7 +4059,7 @@
             <a:r>
               <a:rPr sz="1800">
                 <a:solidFill>
-                  <a:srgbClr val="1F3355"/>
+                  <a:srgbClr val="1F4E6B"/>
                 </a:solidFill>
               </a:rPr>
               <a:t>C.-Y. Li and C.-C. Lo, optimal known/chosen-plaintext bound for permutation-only ciphers, 2011.</a:t>
@@ -4074,7 +4074,7 @@
             <a:r>
               <a:rPr sz="1800">
                 <a:solidFill>
-                  <a:srgbClr val="1F3355"/>
+                  <a:srgbClr val="1F4E6B"/>
                 </a:solidFill>
               </a:rPr>
               <a:t>Y. Wu et al., NPCR and UACI randomness tests for image encryption, 2011.</a:t>
@@ -4123,7 +4123,7 @@
             <a:r>
               <a:rPr sz="4000" b="1">
                 <a:solidFill>
-                  <a:srgbClr val="1F3355"/>
+                  <a:srgbClr val="1F4E6B"/>
                 </a:solidFill>
               </a:rPr>
               <a:t>Thank you</a:t>
@@ -4161,7 +4161,7 @@
             <a:r>
               <a:rPr sz="1800">
                 <a:solidFill>
-                  <a:srgbClr val="1F3355"/>
+                  <a:srgbClr val="1F4E6B"/>
                 </a:solidFill>
               </a:rPr>
               <a:t>Questions?  ·  Reproduction and attack code released for verification.</a:t>
@@ -4205,7 +4205,7 @@
             <a:r>
               <a:rPr sz="3000" b="1">
                 <a:solidFill>
-                  <a:srgbClr val="1F3355"/>
+                  <a:srgbClr val="1F4E6B"/>
                 </a:solidFill>
               </a:rPr>
               <a:t>Introduction: chaos image ciphers keep breaking the same way</a:t>
@@ -4243,7 +4243,7 @@
             <a:r>
               <a:rPr sz="1800">
                 <a:solidFill>
-                  <a:srgbClr val="1F3355"/>
+                  <a:srgbClr val="1F4E6B"/>
                 </a:solidFill>
               </a:rPr>
               <a:t>Chaos-based image ciphers scramble a picture using chaotic (random-looking) math. Most follow a permutation–diffusion design: first shuffle the pixels around (confusion), then mask their values with a keystream, a long random-looking sequence the cipher mixes in (diffusion).</a:t>
@@ -4258,7 +4258,7 @@
             <a:r>
               <a:rPr sz="1800">
                 <a:solidFill>
-                  <a:srgbClr val="1F3355"/>
+                  <a:srgbClr val="1F4E6B"/>
                 </a:solidFill>
               </a:rPr>
               <a:t>Recurring lesson: if that keystream depends only on the secret key (never on the image), the whole cipher is one fixed transformation, so an equivalent key (a stand-in that decrypts any image without being the real key) can be recovered from a few chosen plaintexts (images the attacker picks and has the cipher encrypt).</a:t>
@@ -4273,7 +4273,7 @@
             <a:r>
               <a:rPr sz="1800">
                 <a:solidFill>
-                  <a:srgbClr val="1F3355"/>
+                  <a:srgbClr val="1F4E6B"/>
                 </a:solidFill>
               </a:rPr>
               <a:t>Second problem (method): schemes are judged by statistics: entropy (a randomness score), neighbouring-pixel correlation, NPCR/UACI. Near-ideal values are treated as proof of security.</a:t>
@@ -4288,7 +4288,7 @@
             <a:r>
               <a:rPr sz="1600">
                 <a:solidFill>
-                  <a:srgbClr val="555555"/>
+                  <a:srgbClr val="6B7079"/>
                 </a:solidFill>
               </a:rPr>
               <a:t>But none of those scores tests resistance to a chosen-plaintext attack.</a:t>
@@ -4303,7 +4303,7 @@
             <a:r>
               <a:rPr sz="1800">
                 <a:solidFill>
-                  <a:srgbClr val="1F3355"/>
+                  <a:srgbClr val="1F4E6B"/>
                 </a:solidFill>
               </a:rPr>
               <a:t>Why this matters operationally: image ciphers protect real data: medical scans, sealed evidence, access-controlled documents. A break is not a per-image slip but a standing ability to decrypt every future ciphertext of that size, so security must rest on an attack model, not a statistics table.</a:t>
@@ -4318,7 +4318,7 @@
             <a:r>
               <a:rPr sz="1800">
                 <a:solidFill>
-                  <a:srgbClr val="1F3355"/>
+                  <a:srgbClr val="1F4E6B"/>
                 </a:solidFill>
               </a:rPr>
               <a:t>We apply both lessons to a 2025 scheme: “LLEO” (Jain et al., Optik, 2025).</a:t>
@@ -4362,7 +4362,7 @@
             <a:r>
               <a:rPr sz="3000" b="1">
                 <a:solidFill>
-                  <a:srgbClr val="1F3355"/>
+                  <a:srgbClr val="1F4E6B"/>
                 </a:solidFill>
               </a:rPr>
               <a:t>The target: LLEO (Jain et al., Optik 2025)</a:t>
@@ -4424,7 +4424,7 @@
             <a:r>
               <a:rPr sz="1600">
                 <a:solidFill>
-                  <a:srgbClr val="1F3355"/>
+                  <a:srgbClr val="1F4E6B"/>
                 </a:solidFill>
               </a:rPr>
               <a:t>Two chaotic maps (simple formulas whose output looks random: Lorenz and logistic) make the keystream that masks each pixel (multiply by K).</a:t>
@@ -4439,7 +4439,7 @@
             <a:r>
               <a:rPr sz="1600">
                 <a:solidFill>
-                  <a:srgbClr val="1F3355"/>
+                  <a:srgbClr val="1F4E6B"/>
                 </a:solidFill>
               </a:rPr>
               <a:t>Then two Fisher–Yates shuffles (a standard way to randomly reorder a list) rearrange 16 row-blocks, then 16 column-blocks.</a:t>
@@ -4454,7 +4454,7 @@
             <a:r>
               <a:rPr sz="1600">
                 <a:solidFill>
-                  <a:srgbClr val="1F3355"/>
+                  <a:srgbClr val="1F4E6B"/>
                 </a:solidFill>
               </a:rPr>
               <a:t>Every key element comes from the secret key alone, nothing depends on the image X.</a:t>
@@ -4469,7 +4469,7 @@
             <a:r>
               <a:rPr sz="1600">
                 <a:solidFill>
-                  <a:srgbClr val="1F3355"/>
+                  <a:srgbClr val="1F4E6B"/>
                 </a:solidFill>
               </a:rPr>
               <a:t>Called “asymmetric,” but the same keys both encrypt and decrypt: it is really symmetric.</a:t>
@@ -4503,7 +4503,7 @@
             <a:r>
               <a:rPr sz="1200" i="1">
                 <a:solidFill>
-                  <a:srgbClr val="555555"/>
+                  <a:srgbClr val="6B7079"/>
                 </a:solidFill>
               </a:rPr>
               <a:t>LLEO encryption (top) and the equivalent-key attack (bottom).</a:t>
@@ -4547,7 +4547,7 @@
             <a:r>
               <a:rPr sz="3000" b="1">
                 <a:solidFill>
-                  <a:srgbClr val="1F3355"/>
+                  <a:srgbClr val="1F4E6B"/>
                 </a:solidFill>
               </a:rPr>
               <a:t>Key insight: LLEO is one fixed “multiply-and-reorder” map</a:t>
@@ -4585,7 +4585,7 @@
             <a:r>
               <a:rPr sz="1800">
                 <a:solidFill>
-                  <a:srgbClr val="1F3355"/>
+                  <a:srgbClr val="1F4E6B"/>
                 </a:solidFill>
               </a:rPr>
               <a:t>Write the image as a list of n = M×N pixels. Every step is just multiply-and-reorder using arithmetic that wraps around at 256 (like hours on a clock), and is fixed once the key is set.</a:t>
@@ -4600,7 +4600,7 @@
             <a:r>
               <a:rPr sz="1800">
                 <a:solidFill>
-                  <a:srgbClr val="1F3355"/>
+                  <a:srgbClr val="1F4E6B"/>
                 </a:solidFill>
               </a:rPr>
               <a:t>Masking multiplies pixel p by a fixed odd number K[p] (odd, so it can always be divided back out); the two shuffles combine into one fixed reordering of positions.</a:t>
@@ -4615,7 +4615,7 @@
             <a:r>
               <a:rPr sz="1800">
                 <a:solidFill>
-                  <a:srgbClr val="1F3355"/>
+                  <a:srgbClr val="1F4E6B"/>
                 </a:solidFill>
               </a:rPr>
               <a:t>So  C[j] = K[s(j)] · X[s(j)]  (mod 256): each output pixel is exactly one input pixel times a fixed number, a “monomial” map.</a:t>
@@ -4630,7 +4630,7 @@
             <a:r>
               <a:rPr sz="1800">
                 <a:solidFill>
-                  <a:srgbClr val="1F3355"/>
+                  <a:srgbClr val="1F4E6B"/>
                 </a:solidFill>
               </a:rPr>
               <a:t>Two gifts to the attacker: no added constant, and no diffusion (each output pixel depends on only one input pixel).</a:t>
@@ -4674,7 +4674,7 @@
             <a:r>
               <a:rPr sz="3000" b="1">
                 <a:solidFill>
-                  <a:srgbClr val="1F3355"/>
+                  <a:srgbClr val="1F4E6B"/>
                 </a:solidFill>
               </a:rPr>
               <a:t>Four images recover the full map</a:t>
@@ -4712,7 +4712,7 @@
             <a:r>
               <a:rPr sz="1800">
                 <a:solidFill>
-                  <a:srgbClr val="1F3355"/>
+                  <a:srgbClr val="1F4E6B"/>
                 </a:solidFill>
               </a:rPr>
               <a:t>(a) The multiplier, 1 query: encrypt an all-ones image; the output directly reveals K at every position.</a:t>
@@ -4727,7 +4727,7 @@
             <a:r>
               <a:rPr sz="1800">
                 <a:solidFill>
-                  <a:srgbClr val="1F3355"/>
+                  <a:srgbClr val="1F4E6B"/>
                 </a:solidFill>
               </a:rPr>
               <a:t>(b) The reordering, a few queries: encrypt images whose pixels carry their own position number, then divide out the known K to read off where each pixel came from (the map s).</a:t>
@@ -4742,7 +4742,7 @@
             <a:r>
               <a:rPr sz="1800">
                 <a:solidFill>
-                  <a:srgbClr val="1F3355"/>
+                  <a:srgbClr val="1F4E6B"/>
                 </a:solidFill>
               </a:rPr>
               <a:t>The pair (s, K) is the equivalent key. It inverts any ciphertext:  X[s(j)] = K[s(j)]^-1 · C[j].</a:t>
@@ -4757,7 +4757,7 @@
             <a:r>
               <a:rPr sz="1800">
                 <a:solidFill>
-                  <a:srgbClr val="1F3355"/>
+                  <a:srgbClr val="1F4E6B"/>
                 </a:solidFill>
               </a:rPr>
               <a:t>Total cost: 1 + ceil(log_256 MN) chosen plaintexts = just 4 for a 512×512 image, no matter how long the advertised key is.</a:t>
@@ -4772,7 +4772,7 @@
             <a:r>
               <a:rPr sz="1800">
                 <a:solidFill>
-                  <a:srgbClr val="1F3355"/>
+                  <a:srgbClr val="1F4E6B"/>
                 </a:solidFill>
               </a:rPr>
               <a:t>This matches the known best-possible bound for shuffle-only ciphers; adding more rounds or maps doesn't change the form, so the same attack still works.</a:t>
@@ -4816,7 +4816,7 @@
             <a:r>
               <a:rPr sz="3000" b="1">
                 <a:solidFill>
-                  <a:srgbClr val="1F3355"/>
+                  <a:srgbClr val="1F4E6B"/>
                 </a:solidFill>
               </a:rPr>
               <a:t>Experimental setup</a:t>
@@ -4854,7 +4854,7 @@
             <a:r>
               <a:rPr sz="1800">
                 <a:solidFill>
-                  <a:srgbClr val="1F3355"/>
+                  <a:srgbClr val="1F4E6B"/>
                 </a:solidFill>
               </a:rPr>
               <a:t>Reconstructed LLEO from its published description, reimplemented from scratch, no code reused.</a:t>
@@ -4869,7 +4869,7 @@
             <a:r>
               <a:rPr sz="1800">
                 <a:solidFill>
-                  <a:srgbClr val="1F3355"/>
+                  <a:srgbClr val="1F4E6B"/>
                 </a:solidFill>
               </a:rPr>
               <a:t>Four standard 512×512 grayscale images (Cameraman, Moon, Gravel, Brick); one fixed secret key.</a:t>
@@ -4884,7 +4884,7 @@
             <a:r>
               <a:rPr sz="1800">
                 <a:solidFill>
-                  <a:srgbClr val="1F3355"/>
+                  <a:srgbClr val="1F4E6B"/>
                 </a:solidFill>
               </a:rPr>
               <a:t>Verified the reconstruction reproduces LLEO's reported statistics before attacking.</a:t>
@@ -4899,7 +4899,7 @@
             <a:r>
               <a:rPr sz="1800">
                 <a:solidFill>
-                  <a:srgbClr val="1F3355"/>
+                  <a:srgbClr val="1F4E6B"/>
                 </a:solidFill>
               </a:rPr>
               <a:t>All timings single-core wall-clock.</a:t>
@@ -4943,7 +4943,7 @@
             <a:r>
               <a:rPr sz="3000" b="1">
                 <a:solidFill>
-                  <a:srgbClr val="1F3355"/>
+                  <a:srgbClr val="1F4E6B"/>
                 </a:solidFill>
               </a:rPr>
               <a:t>Result: every image recovered pixel-exactly, without the key</a:t>
@@ -5005,7 +5005,7 @@
             <a:r>
               <a:rPr sz="1600">
                 <a:solidFill>
-                  <a:srgbClr val="1F3355"/>
+                  <a:srgbClr val="1F4E6B"/>
                 </a:solidFill>
               </a:rPr>
               <a:t>Only 4 chosen plaintexts per image.</a:t>
@@ -5020,7 +5020,7 @@
             <a:r>
               <a:rPr sz="1600">
                 <a:solidFill>
-                  <a:srgbClr val="1F3355"/>
+                  <a:srgbClr val="1F4E6B"/>
                 </a:solidFill>
               </a:rPr>
               <a:t>Recovery is bit-identical to the original.</a:t>
@@ -5035,7 +5035,7 @@
             <a:r>
               <a:rPr sz="1600">
                 <a:solidFill>
-                  <a:srgbClr val="1F3355"/>
+                  <a:srgbClr val="1F4E6B"/>
                 </a:solidFill>
               </a:rPr>
               <a:t>Decryption in 0.037 s at 512x512 (single core), no key used.</a:t>
@@ -5069,7 +5069,7 @@
             <a:r>
               <a:rPr sz="1200" i="1">
                 <a:solidFill>
-                  <a:srgbClr val="555555"/>
+                  <a:srgbClr val="6B7079"/>
                 </a:solidFill>
               </a:rPr>
               <a:t>Original -&gt; LLEO ciphertext -&gt; key-free recovery (bit-identical), four images.</a:t>
@@ -5113,7 +5113,7 @@
             <a:r>
               <a:rPr sz="3000" b="1">
                 <a:solidFill>
-                  <a:srgbClr val="1F3355"/>
+                  <a:srgbClr val="1F4E6B"/>
                 </a:solidFill>
               </a:rPr>
               <a:t>Good statistics are not security</a:t>
@@ -5195,7 +5195,7 @@
             <a:r>
               <a:rPr sz="1200" i="1">
                 <a:solidFill>
-                  <a:srgbClr val="555555"/>
+                  <a:srgbClr val="6B7079"/>
                 </a:solidFill>
               </a:rPr>
               <a:t>Flat histogram of cipher pixel values</a:t>
@@ -5229,7 +5229,7 @@
             <a:r>
               <a:rPr sz="1200" i="1">
                 <a:solidFill>
-                  <a:srgbClr val="555555"/>
+                  <a:srgbClr val="6B7079"/>
                 </a:solidFill>
               </a:rPr>
               <a:t>Neighbouring-pixel pattern: structure -&gt; uniform</a:t>
@@ -5267,7 +5267,7 @@
             <a:r>
               <a:rPr sz="1500">
                 <a:solidFill>
-                  <a:srgbClr val="1F3355"/>
+                  <a:srgbClr val="1F4E6B"/>
                 </a:solidFill>
               </a:rPr>
               <a:t>Entropy (a randomness score, maximum 8) rises 7.23 -&gt; 7.99; neighbouring pixels go from very alike to almost unrelated (correlation ~ 0); the spread of pixel values is flat.</a:t>
@@ -5282,7 +5282,7 @@
             <a:r>
               <a:rPr sz="1500">
                 <a:solidFill>
-                  <a:srgbClr val="1F3355"/>
+                  <a:srgbClr val="1F4E6B"/>
                 </a:solidFill>
               </a:rPr>
               <a:t>By every usual yardstick LLEO looks strong, yet it is broken in 4 queries.</a:t>
@@ -5326,7 +5326,7 @@
             <a:r>
               <a:rPr sz="3000" b="1">
                 <a:solidFill>
-                  <a:srgbClr val="1F3355"/>
+                  <a:srgbClr val="1F4E6B"/>
                 </a:solidFill>
               </a:rPr>
               <a:t>The “differential” score (NPCR) is illusory</a:t>
@@ -5388,7 +5388,7 @@
             <a:r>
               <a:rPr sz="1600">
                 <a:solidFill>
-                  <a:srgbClr val="1F3355"/>
+                  <a:srgbClr val="1F4E6B"/>
                 </a:solidFill>
               </a:rPr>
               <a:t>NPCR = the percent of pixels that change when you flip a single input pixel. A good cipher should change almost all of them (~99.6%), and LLEO reports ~99.6%.</a:t>
@@ -5403,7 +5403,7 @@
             <a:r>
               <a:rPr sz="1600">
                 <a:solidFill>
-                  <a:srgbClr val="1F3355"/>
+                  <a:srgbClr val="1F4E6B"/>
                 </a:solidFill>
               </a:rPr>
               <a:t>But with no diffusion, flipping one input pixel changes exactly one output pixel, so the true value is 100/MN ~ 0.0004%, five orders of magnitude smaller.</a:t>
@@ -5418,7 +5418,7 @@
             <a:r>
               <a:rPr sz="1600">
                 <a:solidFill>
-                  <a:srgbClr val="1F3355"/>
+                  <a:srgbClr val="1F4E6B"/>
                 </a:solidFill>
               </a:rPr>
               <a:t>The 99.6% is really just the difference between two unrelated images (here 99.88%), which any near-uniform cipher reaches and which says nothing about security.</a:t>
@@ -5452,7 +5452,7 @@
             <a:r>
               <a:rPr sz="1200" i="1">
                 <a:solidFill>
-                  <a:srgbClr val="555555"/>
+                  <a:srgbClr val="6B7079"/>
                 </a:solidFill>
               </a:rPr>
               <a:t>Difference image |C_0-C_1|: dark = unchanged, bright = changed (one fixed key).</a:t>

</xml_diff>